<commit_message>
Point slide QR to submissions and show event website
</commit_message>
<xml_diff>
--- a/uploads/logic-apps-live-2026/logic-apps-event-qr.pptx
+++ b/uploads/logic-apps-live-2026/logic-apps-event-qr.pptx
@@ -2,13 +2,13 @@
 <file path=ppt/presentation.xml><?xml version="1.0" encoding="utf-8"?>
 <p:presentation xmlns:p="http://schemas.openxmlformats.org/presentationml/2006/main">
   <p:sldMasterIdLst>
-    <p:sldMasterId xmlns:r="http://schemas.openxmlformats.org/officeDocument/2006/relationships" id="2147483648" r:id="Ra173141758054df7"/>
+    <p:sldMasterId xmlns:r="http://schemas.openxmlformats.org/officeDocument/2006/relationships" id="2147483648" r:id="Rbfa1b6228ce844e6"/>
   </p:sldMasterIdLst>
   <p:notesMasterIdLst>
-    <p:notesMasterId xmlns:r="http://schemas.openxmlformats.org/officeDocument/2006/relationships" r:id="R63cca3d2ce1c4ebd"/>
+    <p:notesMasterId xmlns:r="http://schemas.openxmlformats.org/officeDocument/2006/relationships" r:id="Rcea4ee0650b84ec7"/>
   </p:notesMasterIdLst>
   <p:sldIdLst>
-    <p:sldId xmlns:r="http://schemas.openxmlformats.org/officeDocument/2006/relationships" id="256" r:id="R219553bf93ca4dbd"/>
+    <p:sldId xmlns:r="http://schemas.openxmlformats.org/officeDocument/2006/relationships" id="256" r:id="R22b639a5f5444c17"/>
   </p:sldIdLst>
   <p:sldSz cx="18288000" cy="10287000"/>
   <p:notesSz cx="6858000" cy="9144000"/>
@@ -442,7 +442,7 @@
           <a:lstStyle xmlns:a="http://schemas.openxmlformats.org/drawingml/2006/main"/>
           <a:p xmlns:a="http://schemas.openxmlformats.org/drawingml/2006/main">
             <a:r>
-              <a:t>Logic Apps Community Day takes place online on 3 December 2026 at 19:00 CET, live on YouTube and free to attend. The QR code links to https://qbq-hh-sebastian-meyer.github.io/logic-apps-community-day-2026/ for event details. Share the event with colleagues and the community.</a:t>
+              <a:t>Logic Apps Community Day takes place online on 3 December 2026 at 19:00 CET, live on YouTube and free to attend. The QR code links to https://sessionize.com/logic-apps-community-day-2026/ to submit a session. Share the event with colleagues and the community.</a:t>
             </a:r>
           </a:p>
           <a:p xmlns:a="http://schemas.openxmlformats.org/drawingml/2006/main">
@@ -515,7 +515,7 @@
   </p:cSld>
   <p:clrMap bg1="lt1" tx1="dk1" bg2="lt2" tx2="dk2" accent1="accent1" accent2="accent2" accent3="accent3" accent4="accent4" accent5="accent5" accent6="accent6" hlink="hlink" folHlink="folHlink"/>
   <p:sldLayoutIdLst>
-    <p:sldLayoutId xmlns:r="http://schemas.openxmlformats.org/officeDocument/2006/relationships" id="2147483649" r:id="R13cb715fbcb84a8a"/>
+    <p:sldLayoutId xmlns:r="http://schemas.openxmlformats.org/officeDocument/2006/relationships" id="2147483649" r:id="R1057b4acb9374e8e"/>
   </p:sldLayoutIdLst>
   <p:txStyles>
     <p:titleStyle>
@@ -1063,14 +1063,14 @@
       </p:grpSpPr>
       <p:pic>
         <p:nvPicPr>
-          <p:cNvPr id="3" name=""/>
+          <p:cNvPr id="5" name=""/>
           <p:cNvPicPr>
             <a:picLocks xmlns:a="http://schemas.openxmlformats.org/drawingml/2006/main" noChangeAspect="1"/>
           </p:cNvPicPr>
           <p:nvPr/>
         </p:nvPicPr>
         <p:blipFill>
-          <a:blip xmlns:r="http://schemas.openxmlformats.org/officeDocument/2006/relationships" xmlns:a="http://schemas.openxmlformats.org/drawingml/2006/main" r:embed="R27f7b5ebdc9d4e7b"/>
+          <a:blip xmlns:r="http://schemas.openxmlformats.org/officeDocument/2006/relationships" xmlns:a="http://schemas.openxmlformats.org/drawingml/2006/main" r:embed="R11c70c278a4149a6"/>
           <a:stretch xmlns:a="http://schemas.openxmlformats.org/drawingml/2006/main"/>
         </p:blipFill>
         <p:spPr>
@@ -1085,14 +1085,14 @@
       </p:pic>
       <p:pic>
         <p:nvPicPr>
-          <p:cNvPr id="4" name=""/>
+          <p:cNvPr id="6" name=""/>
           <p:cNvPicPr>
             <a:picLocks xmlns:a="http://schemas.openxmlformats.org/drawingml/2006/main" noChangeAspect="1"/>
           </p:cNvPicPr>
           <p:nvPr/>
         </p:nvPicPr>
         <p:blipFill>
-          <a:blip xmlns:r="http://schemas.openxmlformats.org/officeDocument/2006/relationships" xmlns:a="http://schemas.openxmlformats.org/drawingml/2006/main" r:embed="R759f45551f1f4db5"/>
+          <a:blip xmlns:r="http://schemas.openxmlformats.org/officeDocument/2006/relationships" xmlns:a="http://schemas.openxmlformats.org/drawingml/2006/main" r:embed="Ra4f65d057eb94b4b"/>
           <a:stretch xmlns:a="http://schemas.openxmlformats.org/drawingml/2006/main"/>
         </p:blipFill>
         <p:spPr>
@@ -1105,10 +1105,128 @@
           </a:prstGeom>
         </p:spPr>
       </p:pic>
+      <p:sp>
+        <p:nvSpPr>
+          <p:cNvPr id="3" name="">
+            <a:extLst xmlns:a="http://schemas.openxmlformats.org/drawingml/2006/main">
+              <a:ext uri="{FF2B5EF4-FFF2-40B4-BE49-F238E27FC236}">
+                <a16:creationId xmlns:a16="http://schemas.microsoft.com/office/drawing/2014/main" id="{3FE2A06B-ADF0-4982-B9D2-CEE4006D920D}"/>
+              </a:ext>
+            </a:extLst>
+          </p:cNvPr>
+          <p:cNvSpPr>
+            <a:spLocks xmlns:a="http://schemas.openxmlformats.org/drawingml/2006/main" noGrp="1"/>
+          </p:cNvSpPr>
+          <p:nvPr/>
+        </p:nvSpPr>
+        <p:spPr>
+          <a:xfrm xmlns:a="http://schemas.openxmlformats.org/drawingml/2006/main">
+            <a:off x="15240000" y="9620250"/>
+            <a:ext cx="2762250" cy="381000"/>
+          </a:xfrm>
+          <a:prstGeom xmlns:a="http://schemas.openxmlformats.org/drawingml/2006/main" prst="rect">
+            <a:avLst/>
+          </a:prstGeom>
+          <a:solidFill xmlns:a="http://schemas.openxmlformats.org/drawingml/2006/main">
+            <a:srgbClr val="030B2B"/>
+          </a:solidFill>
+          <a:ln xmlns:a="http://schemas.openxmlformats.org/drawingml/2006/main" w="0">
+            <a:noFill/>
+          </a:ln>
+        </p:spPr>
+        <p:txBody>
+          <a:bodyPr xmlns:a="http://schemas.openxmlformats.org/drawingml/2006/main">
+            <a:noAutofit/>
+          </a:bodyPr>
+          <a:lstStyle xmlns:a="http://schemas.openxmlformats.org/drawingml/2006/main"/>
+          <a:p xmlns:a="http://schemas.openxmlformats.org/drawingml/2006/main">
+            <a:pPr algn="ctr">
+              <a:defRPr sz="1650" b="1">
+                <a:solidFill>
+                  <a:srgbClr val="FFFFFF"/>
+                </a:solidFill>
+                <a:latin typeface="Arial"/>
+                <a:ea typeface="Arial"/>
+                <a:cs typeface="Arial"/>
+              </a:defRPr>
+            </a:pPr>
+            <a:r>
+              <a:rPr sz="1650" b="1">
+                <a:solidFill>
+                  <a:srgbClr val="FFFFFF"/>
+                </a:solidFill>
+                <a:latin typeface="Arial"/>
+                <a:ea typeface="Arial"/>
+                <a:cs typeface="Arial"/>
+              </a:rPr>
+              <a:t>SUBMIT YOUR TALK</a:t>
+            </a:r>
+          </a:p>
+        </p:txBody>
+      </p:sp>
+      <p:sp>
+        <p:nvSpPr>
+          <p:cNvPr id="4" name="">
+            <a:extLst xmlns:a="http://schemas.openxmlformats.org/drawingml/2006/main">
+              <a:ext uri="{FF2B5EF4-FFF2-40B4-BE49-F238E27FC236}">
+                <a16:creationId xmlns:a16="http://schemas.microsoft.com/office/drawing/2014/main" id="{0330D588-036E-444F-9029-EC398167EB17}"/>
+              </a:ext>
+            </a:extLst>
+          </p:cNvPr>
+          <p:cNvSpPr>
+            <a:spLocks xmlns:a="http://schemas.openxmlformats.org/drawingml/2006/main" noGrp="1"/>
+          </p:cNvSpPr>
+          <p:nvPr/>
+        </p:nvSpPr>
+        <p:spPr>
+          <a:xfrm xmlns:a="http://schemas.openxmlformats.org/drawingml/2006/main">
+            <a:off x="1619250" y="9953625"/>
+            <a:ext cx="13144500" cy="285750"/>
+          </a:xfrm>
+          <a:prstGeom xmlns:a="http://schemas.openxmlformats.org/drawingml/2006/main" prst="rect">
+            <a:avLst/>
+          </a:prstGeom>
+          <a:solidFill xmlns:a="http://schemas.openxmlformats.org/drawingml/2006/main">
+            <a:srgbClr val="030B2B"/>
+          </a:solidFill>
+          <a:ln xmlns:a="http://schemas.openxmlformats.org/drawingml/2006/main" w="0">
+            <a:noFill/>
+          </a:ln>
+        </p:spPr>
+        <p:txBody>
+          <a:bodyPr xmlns:a="http://schemas.openxmlformats.org/drawingml/2006/main">
+            <a:noAutofit/>
+          </a:bodyPr>
+          <a:lstStyle xmlns:a="http://schemas.openxmlformats.org/drawingml/2006/main"/>
+          <a:p xmlns:a="http://schemas.openxmlformats.org/drawingml/2006/main">
+            <a:pPr algn="ctr">
+              <a:defRPr sz="1725">
+                <a:solidFill>
+                  <a:srgbClr val="B9F9FF"/>
+                </a:solidFill>
+                <a:latin typeface="Arial"/>
+                <a:ea typeface="Arial"/>
+                <a:cs typeface="Arial"/>
+              </a:defRPr>
+            </a:pPr>
+            <a:r>
+              <a:rPr sz="1725">
+                <a:solidFill>
+                  <a:srgbClr val="B9F9FF"/>
+                </a:solidFill>
+                <a:latin typeface="Arial"/>
+                <a:ea typeface="Arial"/>
+                <a:cs typeface="Arial"/>
+              </a:rPr>
+              <a:t>qbq-hh-sebastian-meyer.github.io/logic-apps-community-day-2026</a:t>
+            </a:r>
+          </a:p>
+        </p:txBody>
+      </p:sp>
     </p:spTree>
     <p:extLst>
       <p:ext uri="{BB962C8B-B14F-4D97-AF65-F5344CB8AC3E}">
-        <p14:creationId xmlns:p14="http://schemas.microsoft.com/office/powerpoint/2010/main" val="794513064"/>
+        <p14:creationId xmlns:p14="http://schemas.microsoft.com/office/powerpoint/2010/main" val="1259030357"/>
       </p:ext>
     </p:extLst>
   </p:cSld>

</xml_diff>